<commit_message>
Refine coursework wording and metadata; stage lab revision
</commit_message>
<xml_diff>
--- a/submissions/initial-phases/A_Aspiration/ClassMic_A2_Three_Slides.pptx
+++ b/submissions/initial-phases/A_Aspiration/ClassMic_A2_Three_Slides.pptx
@@ -2,39 +2,39 @@
 <file path=ppt/presentation.xml><?xml version="1.0" encoding="utf-8"?>
 <p:presentation xmlns:p="http://schemas.openxmlformats.org/presentationml/2006/main" embedTrueTypeFonts="1" saveSubsetFonts="0">
   <p:sldMasterIdLst>
-    <p:sldMasterId xmlns:r="http://schemas.openxmlformats.org/officeDocument/2006/relationships" id="2147483648" r:id="R0d207cdd30674956"/>
+    <p:sldMasterId xmlns:r="http://schemas.openxmlformats.org/officeDocument/2006/relationships" id="2147483648" r:id="Ra11ab537df4c4f78"/>
   </p:sldMasterIdLst>
   <p:notesMasterIdLst>
-    <p:notesMasterId xmlns:r="http://schemas.openxmlformats.org/officeDocument/2006/relationships" r:id="Rbf941ea14e434d99"/>
+    <p:notesMasterId xmlns:r="http://schemas.openxmlformats.org/officeDocument/2006/relationships" r:id="R575028220d654f54"/>
   </p:notesMasterIdLst>
   <p:sldIdLst>
-    <p:sldId xmlns:r="http://schemas.openxmlformats.org/officeDocument/2006/relationships" id="256" r:id="R7489a34cd66f4bb5"/>
-    <p:sldId xmlns:r="http://schemas.openxmlformats.org/officeDocument/2006/relationships" id="257" r:id="Rcc1984fc69834e5c"/>
-    <p:sldId xmlns:r="http://schemas.openxmlformats.org/officeDocument/2006/relationships" id="258" r:id="R0023a51fd0544aab"/>
+    <p:sldId xmlns:r="http://schemas.openxmlformats.org/officeDocument/2006/relationships" id="256" r:id="R49192092324e4dd6"/>
+    <p:sldId xmlns:r="http://schemas.openxmlformats.org/officeDocument/2006/relationships" id="257" r:id="R0ce83c9595a7412e"/>
+    <p:sldId xmlns:r="http://schemas.openxmlformats.org/officeDocument/2006/relationships" id="258" r:id="R27d238f8cb5146b2"/>
   </p:sldIdLst>
   <p:sldSz cx="12192000" cy="6858000"/>
   <p:notesSz cx="6858000" cy="9144000"/>
   <p:embeddedFontLst>
     <p:embeddedFont>
       <p:font typeface="Inter"/>
-      <p:regular xmlns:r="http://schemas.openxmlformats.org/officeDocument/2006/relationships" r:id="Ra27db88d2260405d"/>
-      <p:bold xmlns:r="http://schemas.openxmlformats.org/officeDocument/2006/relationships" r:id="R2e6f226aa7d947e3"/>
+      <p:regular xmlns:r="http://schemas.openxmlformats.org/officeDocument/2006/relationships" r:id="Rf4e9cb5dba2248e5"/>
+      <p:bold xmlns:r="http://schemas.openxmlformats.org/officeDocument/2006/relationships" r:id="R1e54b02b78624ba5"/>
     </p:embeddedFont>
     <p:embeddedFont>
       <p:font typeface="Inter Medium"/>
-      <p:regular xmlns:r="http://schemas.openxmlformats.org/officeDocument/2006/relationships" r:id="Rb89a566530d94837"/>
+      <p:regular xmlns:r="http://schemas.openxmlformats.org/officeDocument/2006/relationships" r:id="R4ef18c147263448f"/>
     </p:embeddedFont>
     <p:embeddedFont>
       <p:font typeface="Inter SemiBold"/>
-      <p:regular xmlns:r="http://schemas.openxmlformats.org/officeDocument/2006/relationships" r:id="R1536cd0a3f044a65"/>
-      <p:bold xmlns:r="http://schemas.openxmlformats.org/officeDocument/2006/relationships" r:id="Rf8418b4fb1dd4930"/>
+      <p:regular xmlns:r="http://schemas.openxmlformats.org/officeDocument/2006/relationships" r:id="R9d5b4dbef42f45fb"/>
+      <p:bold xmlns:r="http://schemas.openxmlformats.org/officeDocument/2006/relationships" r:id="R852cb5d8edfe4334"/>
     </p:embeddedFont>
     <p:embeddedFont>
       <p:font typeface="OpenAI Sans"/>
-      <p:regular xmlns:r="http://schemas.openxmlformats.org/officeDocument/2006/relationships" r:id="R7eba54c6a1cf4f74"/>
-      <p:bold xmlns:r="http://schemas.openxmlformats.org/officeDocument/2006/relationships" r:id="R978d4f2d5b77437b"/>
-      <p:italic xmlns:r="http://schemas.openxmlformats.org/officeDocument/2006/relationships" r:id="R174f4d2ed57543ce"/>
-      <p:boldItalic xmlns:r="http://schemas.openxmlformats.org/officeDocument/2006/relationships" r:id="Rceab676634644317"/>
+      <p:regular xmlns:r="http://schemas.openxmlformats.org/officeDocument/2006/relationships" r:id="R9206fab552224f9e"/>
+      <p:bold xmlns:r="http://schemas.openxmlformats.org/officeDocument/2006/relationships" r:id="Ra891cdbb194247b3"/>
+      <p:italic xmlns:r="http://schemas.openxmlformats.org/officeDocument/2006/relationships" r:id="Rb5a5b5937e81400b"/>
+      <p:boldItalic xmlns:r="http://schemas.openxmlformats.org/officeDocument/2006/relationships" r:id="Rc300e276c5004b9c"/>
     </p:embeddedFont>
   </p:embeddedFontLst>
 </p:presentation>
@@ -422,7 +422,7 @@
               <a:buNone/>
             </a:pPr>
             <a:r>
-              <a:t>ClassMic proposes a controlled classroom microphone prototype. Demand and performance are hypotheses to test.</a:t>
+              <a:t>The prototype will test audibility and ease of use in a controlled setting. Local user feedback is needed before a classroom pilot.</a:t>
             </a:r>
             <a:endParaRPr/>
           </a:p>
@@ -493,7 +493,7 @@
           <a:lstStyle xmlns:a="http://schemas.openxmlformats.org/drawingml/2006/main"/>
           <a:p xmlns:a="http://schemas.openxmlformats.org/drawingml/2006/main">
             <a:r>
-              <a:t>Nurtore Arynuruly is the proposed project manager and Temiko Machavariani the proposed technical lead. Participation by reviewers depends on availability.</a:t>
+              <a:t>The proposed role split puts development and testing with Temiko Machavariani and requirements and delivery coordination with Nurtore Arynuruly. The schedule assumes both have enough time for their assigned work.</a:t>
             </a:r>
           </a:p>
         </p:txBody>
@@ -572,7 +572,7 @@
               <a:buNone/>
             </a:pPr>
             <a:r>
-              <a:t>Targets describe a small feasibility study. Report the actual feedback numerator and denominator. Measure one-way audio delay separately from speaking activation.</a:t>
+              <a:t>Record positive and total feedback counts. Measure one-way audio delay separately from the time between instructor approval and audible speech. The delay target is a 95th percentile of 150 ms or less.</a:t>
             </a:r>
             <a:endParaRPr/>
           </a:p>
@@ -739,7 +739,7 @@
     <p:bg>
       <p:bgPr>
         <a:blipFill xmlns:a="http://schemas.openxmlformats.org/drawingml/2006/main" rotWithShape="1">
-          <a:blip xmlns:r="http://schemas.openxmlformats.org/officeDocument/2006/relationships" r:embed="Ra9534befef2142eb">
+          <a:blip xmlns:r="http://schemas.openxmlformats.org/officeDocument/2006/relationships" r:embed="R25a31965894c43fd">
             <a:lum/>
           </a:blip>
           <a:srcRect l="0" t="0" r="0" b="0"/>
@@ -2279,7 +2279,7 @@
     <p:bg>
       <p:bgPr>
         <a:blipFill xmlns:a="http://schemas.openxmlformats.org/drawingml/2006/main" rotWithShape="1">
-          <a:blip xmlns:r="http://schemas.openxmlformats.org/officeDocument/2006/relationships" r:embed="Rcb2a89ca2f834cd2">
+          <a:blip xmlns:r="http://schemas.openxmlformats.org/officeDocument/2006/relationships" r:embed="R2b3551c93b154f8b">
             <a:lum/>
           </a:blip>
           <a:srcRect l="0" t="0" r="0" b="0"/>
@@ -2523,16 +2523,16 @@
   </p:cSld>
   <p:clrMap bg1="lt1" tx1="dk1" bg2="lt2" tx2="dk2" accent1="accent1" accent2="accent2" accent3="accent3" accent4="accent4" accent5="accent5" accent6="accent6" hlink="hlink" folHlink="folHlink"/>
   <p:sldLayoutIdLst>
-    <p:sldLayoutId xmlns:r="http://schemas.openxmlformats.org/officeDocument/2006/relationships" id="2147483649" r:id="Rcfb0aedc932e4f47"/>
-    <p:sldLayoutId xmlns:r="http://schemas.openxmlformats.org/officeDocument/2006/relationships" id="2147483650" r:id="R22f00b75b0734f23"/>
-    <p:sldLayoutId xmlns:r="http://schemas.openxmlformats.org/officeDocument/2006/relationships" id="2147483651" r:id="R139b4cb3b39a41c8"/>
-    <p:sldLayoutId xmlns:r="http://schemas.openxmlformats.org/officeDocument/2006/relationships" id="2147483652" r:id="R6c034508db884623"/>
-    <p:sldLayoutId xmlns:r="http://schemas.openxmlformats.org/officeDocument/2006/relationships" id="2147483653" r:id="R4381b6fd1b444138"/>
-    <p:sldLayoutId xmlns:r="http://schemas.openxmlformats.org/officeDocument/2006/relationships" id="2147483654" r:id="Rab7116c82a85442d"/>
-    <p:sldLayoutId xmlns:r="http://schemas.openxmlformats.org/officeDocument/2006/relationships" id="2147483655" r:id="Rf94ae598ceff47c1"/>
-    <p:sldLayoutId xmlns:r="http://schemas.openxmlformats.org/officeDocument/2006/relationships" id="2147483656" r:id="R4f7a1fc04bbb4ba7"/>
-    <p:sldLayoutId xmlns:r="http://schemas.openxmlformats.org/officeDocument/2006/relationships" id="2147483657" r:id="Rd4dc394960d5445e"/>
-    <p:sldLayoutId xmlns:r="http://schemas.openxmlformats.org/officeDocument/2006/relationships" id="2147483658" r:id="R409cda01b7a34efd"/>
+    <p:sldLayoutId xmlns:r="http://schemas.openxmlformats.org/officeDocument/2006/relationships" id="2147483649" r:id="Ra0b94f4f15b14b2c"/>
+    <p:sldLayoutId xmlns:r="http://schemas.openxmlformats.org/officeDocument/2006/relationships" id="2147483650" r:id="R273d77d8a0074820"/>
+    <p:sldLayoutId xmlns:r="http://schemas.openxmlformats.org/officeDocument/2006/relationships" id="2147483651" r:id="R5447410e5fff4374"/>
+    <p:sldLayoutId xmlns:r="http://schemas.openxmlformats.org/officeDocument/2006/relationships" id="2147483652" r:id="Re3ffe8fe82274d6c"/>
+    <p:sldLayoutId xmlns:r="http://schemas.openxmlformats.org/officeDocument/2006/relationships" id="2147483653" r:id="Ra918809ef74c4131"/>
+    <p:sldLayoutId xmlns:r="http://schemas.openxmlformats.org/officeDocument/2006/relationships" id="2147483654" r:id="Rb2230dea57b1406f"/>
+    <p:sldLayoutId xmlns:r="http://schemas.openxmlformats.org/officeDocument/2006/relationships" id="2147483655" r:id="R9d98fc972a364951"/>
+    <p:sldLayoutId xmlns:r="http://schemas.openxmlformats.org/officeDocument/2006/relationships" id="2147483656" r:id="R4cea0ba3e0e64e3a"/>
+    <p:sldLayoutId xmlns:r="http://schemas.openxmlformats.org/officeDocument/2006/relationships" id="2147483657" r:id="R224f2f95cfda4df7"/>
+    <p:sldLayoutId xmlns:r="http://schemas.openxmlformats.org/officeDocument/2006/relationships" id="2147483658" r:id="Rbfe091426c854caf"/>
   </p:sldLayoutIdLst>
   <p:hf hdr="0" dt="0"/>
   <p:txStyles>
@@ -3487,7 +3487,7 @@
                 <a:ea typeface="Helvetica Neue"/>
                 <a:cs typeface="Helvetica Neue"/>
               </a:rPr>
-              <a:t>When a question is hard to hear, the instructor may need to repeat it or pass a microphone. Local frequency is unmeasured.</a:t>
+              <a:t>Quiet questions may need repeating or a microphone. We have not yet measured how often this happens in our classes.</a:t>
             </a:r>
           </a:p>
         </p:txBody>
@@ -4367,7 +4367,7 @@
                 <a:ea typeface="Helvetica Neue"/>
                 <a:cs typeface="Helvetica Neue"/>
               </a:rPr>
-              <a:t>The proposed phone microphone workflow needs local demand and performance testing.</a:t>
+              <a:t>Test whether students can use phone microphones easily and whether the room can hear them clearly.</a:t>
             </a:r>
           </a:p>
         </p:txBody>
@@ -5449,7 +5449,7 @@
                 <a:ea typeface="Helvetica Neue"/>
                 <a:cs typeface="Helvetica Neue"/>
               </a:rPr>
-              <a:t>Speakers need a simple way to request a turn. Listeners need clear audio. Participation stays optional, with an alternative speaking path.</a:t>
+              <a:t>Students need an easy way to request a turn and hear one another. A physical microphone or instructor repetition remains available.</a:t>
             </a:r>
           </a:p>
         </p:txBody>
@@ -5584,7 +5584,7 @@
                 <a:ea typeface="Helvetica Neue"/>
                 <a:cs typeface="Helvetica Neue"/>
               </a:rPr>
-              <a:t>Operators need approval, mute and end controls that fit classroom discussion. Their feedback will shape the workflow.</a:t>
+              <a:t>Instructors need to approve a speaker, mute the microphone and end a session without disrupting discussion.</a:t>
             </a:r>
           </a:p>
         </p:txBody>
@@ -5632,7 +5632,7 @@
                 <a:ea typeface="Helvetica Neue"/>
                 <a:cs typeface="Helvetica Neue"/>
               </a:rPr>
-              <a:t>People and decisions</a:t>
+              <a:t>Stakeholders</a:t>
             </a:r>
           </a:p>
         </p:txBody>
@@ -5877,18 +5877,7 @@
                 <a:ea typeface="Helvetica Neue"/>
                 <a:cs typeface="Helvetica Neue"/>
               </a:rPr>
-              <a:t>Temiko leads the prototype. Nurtore coordinates requirements, delivery and evaluation. </a:t>
-            </a:r>
-            <a:r>
-              <a:rPr sz="1800">
-                <a:solidFill>
-                  <a:prstClr val="black"/>
-                </a:solidFill>
-                <a:latin typeface="Helvetica Neue"/>
-                <a:ea typeface="Helvetica Neue"/>
-                <a:cs typeface="Helvetica Neue"/>
-              </a:rPr>
-              <a:t>These are proposed planning responsibilities.</a:t>
+              <a:t>Proposed roles: Temiko leads development and testing. Nurtore coordinates requirements, delivery and evaluation.</a:t>
             </a:r>
             <a:endParaRPr sz="1800">
               <a:solidFill>
@@ -6141,7 +6130,7 @@
                 <a:ea typeface="Helvetica Neue"/>
                 <a:cs typeface="Helvetica Neue"/>
               </a:rPr>
-              <a:t>The course instructor is the proposed acceptance authority. Device, sound and accessibility advice depends on available reviewers.</a:t>
+              <a:t>The course instructor reviews deliverables. Technical and accessibility advisers may help if a room test can be arranged.</a:t>
             </a:r>
             <a:endParaRPr sz="1800">
               <a:solidFill>
@@ -6551,7 +6540,7 @@
                 <a:ea typeface="Helvetica Neue Medium"/>
                 <a:cs typeface="Helvetica Neue Medium"/>
               </a:rPr>
-              <a:t>Course feasibility test</a:t>
+              <a:t>Prototype evaluation</a:t>
             </a:r>
           </a:p>
           <a:p xmlns:a="http://schemas.openxmlformats.org/drawingml/2006/main">
@@ -6576,7 +6565,7 @@
                 <a:ea typeface="Helvetica Neue"/>
                 <a:cs typeface="Helvetica Neue"/>
               </a:rPr>
-              <a:t>Five priority user stories, two weekly sprints and a report of actual results. These targets are proposals, not measured outcomes.</a:t>
+              <a:t>Build five priority user stories in two weekly sprints. Evaluate the prototype against these targets.</a:t>
             </a:r>
           </a:p>
         </p:txBody>
@@ -6865,7 +6854,7 @@
                           <a:ea typeface="Helvetica Neue"/>
                           <a:cs typeface="Helvetica Neue"/>
                         </a:rPr>
-                        <a:t>Complete scope</a:t>
+                        <a:t>Prototype scope</a:t>
                       </a:r>
                       <a:endParaRPr sz="1400">
                         <a:solidFill>
@@ -6938,7 +6927,7 @@
                           <a:ea typeface="Helvetica Neue"/>
                           <a:cs typeface="Helvetica Neue"/>
                         </a:rPr>
-                        <a:t>Five stories and all Must checks</a:t>
+                        <a:t>Five stories and all required checks</a:t>
                       </a:r>
                       <a:endParaRPr sz="1400">
                         <a:solidFill>
@@ -7439,7 +7428,7 @@
                           <a:ea typeface="Helvetica Neue"/>
                           <a:cs typeface="Helvetica Neue"/>
                         </a:rPr>
-                        <a:t>Counts and sample limits</a:t>
+                        <a:t>Feedback counts</a:t>
                       </a:r>
                       <a:endParaRPr sz="1400">
                         <a:solidFill>

</xml_diff>